<commit_message>
Save final pitch deck edits before removing internship material
Keeps the 2026-07-29 edits recoverable in history; the next commit deletes
the deck along with the rest of the internship artifacts.

Co-Authored-By: Claude Opus 5.5 <noreply@anthropic.com>
</commit_message>
<xml_diff>
--- a/docs/pitch_deck.pptx
+++ b/docs/pitch_deck.pptx
@@ -1494,7 +1494,7 @@
           <a:p>
             <a:fld id="{5BCAD085-E8A6-8845-BD4E-CB4CCA059FC4}" type="datetimeFigureOut">
               <a:rPr lang="en-US" smtClean="0"/>
-              <a:t>7/26/2026</a:t>
+              <a:t>7/27/2026</a:t>
             </a:fld>
             <a:endParaRPr lang="en-US"/>
           </a:p>
@@ -1662,7 +1662,7 @@
           <a:p>
             <a:fld id="{5BCAD085-E8A6-8845-BD4E-CB4CCA059FC4}" type="datetimeFigureOut">
               <a:rPr lang="en-US" smtClean="0"/>
-              <a:t>7/26/2026</a:t>
+              <a:t>7/27/2026</a:t>
             </a:fld>
             <a:endParaRPr lang="en-US"/>
           </a:p>
@@ -1840,7 +1840,7 @@
           <a:p>
             <a:fld id="{5BCAD085-E8A6-8845-BD4E-CB4CCA059FC4}" type="datetimeFigureOut">
               <a:rPr lang="en-US" smtClean="0"/>
-              <a:t>7/26/2026</a:t>
+              <a:t>7/27/2026</a:t>
             </a:fld>
             <a:endParaRPr lang="en-US"/>
           </a:p>
@@ -2008,7 +2008,7 @@
           <a:p>
             <a:fld id="{5BCAD085-E8A6-8845-BD4E-CB4CCA059FC4}" type="datetimeFigureOut">
               <a:rPr lang="en-US" smtClean="0"/>
-              <a:t>7/26/2026</a:t>
+              <a:t>7/27/2026</a:t>
             </a:fld>
             <a:endParaRPr lang="en-US"/>
           </a:p>
@@ -2253,7 +2253,7 @@
           <a:p>
             <a:fld id="{5BCAD085-E8A6-8845-BD4E-CB4CCA059FC4}" type="datetimeFigureOut">
               <a:rPr lang="en-US" smtClean="0"/>
-              <a:t>7/26/2026</a:t>
+              <a:t>7/27/2026</a:t>
             </a:fld>
             <a:endParaRPr lang="en-US"/>
           </a:p>
@@ -2538,7 +2538,7 @@
           <a:p>
             <a:fld id="{5BCAD085-E8A6-8845-BD4E-CB4CCA059FC4}" type="datetimeFigureOut">
               <a:rPr lang="en-US" smtClean="0"/>
-              <a:t>7/26/2026</a:t>
+              <a:t>7/27/2026</a:t>
             </a:fld>
             <a:endParaRPr lang="en-US"/>
           </a:p>
@@ -2957,7 +2957,7 @@
           <a:p>
             <a:fld id="{5BCAD085-E8A6-8845-BD4E-CB4CCA059FC4}" type="datetimeFigureOut">
               <a:rPr lang="en-US" smtClean="0"/>
-              <a:t>7/26/2026</a:t>
+              <a:t>7/27/2026</a:t>
             </a:fld>
             <a:endParaRPr lang="en-US"/>
           </a:p>
@@ -3074,7 +3074,7 @@
           <a:p>
             <a:fld id="{5BCAD085-E8A6-8845-BD4E-CB4CCA059FC4}" type="datetimeFigureOut">
               <a:rPr lang="en-US" smtClean="0"/>
-              <a:t>7/26/2026</a:t>
+              <a:t>7/27/2026</a:t>
             </a:fld>
             <a:endParaRPr lang="en-US"/>
           </a:p>
@@ -3169,7 +3169,7 @@
           <a:p>
             <a:fld id="{5BCAD085-E8A6-8845-BD4E-CB4CCA059FC4}" type="datetimeFigureOut">
               <a:rPr lang="en-US" smtClean="0"/>
-              <a:t>7/26/2026</a:t>
+              <a:t>7/27/2026</a:t>
             </a:fld>
             <a:endParaRPr lang="en-US"/>
           </a:p>
@@ -3444,7 +3444,7 @@
           <a:p>
             <a:fld id="{5BCAD085-E8A6-8845-BD4E-CB4CCA059FC4}" type="datetimeFigureOut">
               <a:rPr lang="en-US" smtClean="0"/>
-              <a:t>7/26/2026</a:t>
+              <a:t>7/27/2026</a:t>
             </a:fld>
             <a:endParaRPr lang="en-US"/>
           </a:p>
@@ -3696,7 +3696,7 @@
           <a:p>
             <a:fld id="{5BCAD085-E8A6-8845-BD4E-CB4CCA059FC4}" type="datetimeFigureOut">
               <a:rPr lang="en-US" smtClean="0"/>
-              <a:t>7/26/2026</a:t>
+              <a:t>7/27/2026</a:t>
             </a:fld>
             <a:endParaRPr lang="en-US"/>
           </a:p>
@@ -3907,7 +3907,7 @@
           <a:p>
             <a:fld id="{5BCAD085-E8A6-8845-BD4E-CB4CCA059FC4}" type="datetimeFigureOut">
               <a:rPr lang="en-US" smtClean="0"/>
-              <a:t>7/26/2026</a:t>
+              <a:t>7/27/2026</a:t>
             </a:fld>
             <a:endParaRPr lang="en-US"/>
           </a:p>
@@ -4517,7 +4517,7 @@
         </p:nvSpPr>
         <p:spPr>
           <a:xfrm>
-            <a:off x="594360" y="4343400"/>
+            <a:off x="640080" y="4352431"/>
             <a:ext cx="1005840" cy="44450"/>
           </a:xfrm>
           <a:prstGeom prst="rect">

</xml_diff>